<commit_message>
feat: add AI agent runtime, backend infrastructure, agent architecture documentation, and frontend game components
</commit_message>
<xml_diff>
--- a/assets/pitch-deck/SmartDuka_Pitchdeck.pptx
+++ b/assets/pitch-deck/SmartDuka_Pitchdeck.pptx
@@ -5,16 +5,16 @@
     <p:sldMasterId id="2147483648" r:id="rId1"/>
   </p:sldMasterIdLst>
   <p:sldIdLst>
-    <p:sldId id="256" r:id="rId7"/>
-    <p:sldId id="257" r:id="rId8"/>
-    <p:sldId id="258" r:id="rId9"/>
-    <p:sldId id="259" r:id="rId10"/>
-    <p:sldId id="260" r:id="rId11"/>
-    <p:sldId id="261" r:id="rId12"/>
-    <p:sldId id="262" r:id="rId13"/>
-    <p:sldId id="263" r:id="rId14"/>
+    <p:sldId id="256" r:id="rId2"/>
+    <p:sldId id="257" r:id="rId3"/>
+    <p:sldId id="258" r:id="rId4"/>
+    <p:sldId id="259" r:id="rId5"/>
+    <p:sldId id="260" r:id="rId6"/>
+    <p:sldId id="261" r:id="rId7"/>
+    <p:sldId id="262" r:id="rId8"/>
+    <p:sldId id="263" r:id="rId9"/>
   </p:sldIdLst>
-  <p:sldSz cx="12191695" cy="6858000" type="screen4x3"/>
+  <p:sldSz cx="12192000" cy="6858000"/>
   <p:notesSz cx="6858000" cy="9144000"/>
   <p:defaultTextStyle>
     <a:defPPr>
@@ -111,6 +111,22 @@
       </a:defRPr>
     </a:lvl9pPr>
   </p:defaultTextStyle>
+  <p:extLst>
+    <p:ext uri="{EFAFB233-063F-42B5-8137-9DF3F51BA10A}">
+      <p15:sldGuideLst xmlns:p15="http://schemas.microsoft.com/office/powerpoint/2012/main">
+        <p15:guide id="1" orient="horz" pos="2160">
+          <p15:clr>
+            <a:srgbClr val="A4A3A4"/>
+          </p15:clr>
+        </p15:guide>
+        <p15:guide id="2" pos="2880">
+          <p15:clr>
+            <a:srgbClr val="A4A3A4"/>
+          </p15:clr>
+        </p15:guide>
+      </p15:sldGuideLst>
+    </p:ext>
+  </p:extLst>
 </p:presentation>
 </file>
 
@@ -152,10 +168,9 @@
           <a:lstStyle/>
           <a:p>
             <a:r>
-              <a:rPr lang="en-US" smtClean="0"/>
+              <a:rPr lang="en-US"/>
               <a:t>Click to edit Master title style</a:t>
             </a:r>
-            <a:endParaRPr lang="en-US"/>
           </a:p>
         </p:txBody>
       </p:sp>
@@ -271,10 +286,9 @@
           </a:lstStyle>
           <a:p>
             <a:r>
-              <a:rPr lang="en-US" smtClean="0"/>
+              <a:rPr lang="en-US"/>
               <a:t>Click to edit Master subtitle style</a:t>
             </a:r>
-            <a:endParaRPr lang="en-US"/>
           </a:p>
         </p:txBody>
       </p:sp>
@@ -295,7 +309,7 @@
           <a:p>
             <a:fld id="{5BCAD085-E8A6-8845-BD4E-CB4CCA059FC4}" type="datetimeFigureOut">
               <a:rPr lang="en-US" smtClean="0"/>
-              <a:t>1/27/13</a:t>
+              <a:t>9/25/2026</a:t>
             </a:fld>
             <a:endParaRPr lang="en-US"/>
           </a:p>
@@ -389,10 +403,9 @@
           <a:lstStyle/>
           <a:p>
             <a:r>
-              <a:rPr lang="en-US" smtClean="0"/>
+              <a:rPr lang="en-US"/>
               <a:t>Click to edit Master title style</a:t>
             </a:r>
-            <a:endParaRPr lang="en-US"/>
           </a:p>
         </p:txBody>
       </p:sp>
@@ -413,38 +426,37 @@
           <a:p>
             <a:pPr lvl="0"/>
             <a:r>
-              <a:rPr lang="en-US" smtClean="0"/>
+              <a:rPr lang="en-US"/>
               <a:t>Click to edit Master text styles</a:t>
             </a:r>
           </a:p>
           <a:p>
             <a:pPr lvl="1"/>
             <a:r>
-              <a:rPr lang="en-US" smtClean="0"/>
+              <a:rPr lang="en-US"/>
               <a:t>Second level</a:t>
             </a:r>
           </a:p>
           <a:p>
             <a:pPr lvl="2"/>
             <a:r>
-              <a:rPr lang="en-US" smtClean="0"/>
+              <a:rPr lang="en-US"/>
               <a:t>Third level</a:t>
             </a:r>
           </a:p>
           <a:p>
             <a:pPr lvl="3"/>
             <a:r>
-              <a:rPr lang="en-US" smtClean="0"/>
+              <a:rPr lang="en-US"/>
               <a:t>Fourth level</a:t>
             </a:r>
           </a:p>
           <a:p>
             <a:pPr lvl="4"/>
             <a:r>
-              <a:rPr lang="en-US" smtClean="0"/>
+              <a:rPr lang="en-US"/>
               <a:t>Fifth level</a:t>
             </a:r>
-            <a:endParaRPr lang="en-US"/>
           </a:p>
         </p:txBody>
       </p:sp>
@@ -465,7 +477,7 @@
           <a:p>
             <a:fld id="{5BCAD085-E8A6-8845-BD4E-CB4CCA059FC4}" type="datetimeFigureOut">
               <a:rPr lang="en-US" smtClean="0"/>
-              <a:t>1/27/13</a:t>
+              <a:t>9/25/2026</a:t>
             </a:fld>
             <a:endParaRPr lang="en-US"/>
           </a:p>
@@ -564,10 +576,9 @@
           <a:lstStyle/>
           <a:p>
             <a:r>
-              <a:rPr lang="en-US" smtClean="0"/>
+              <a:rPr lang="en-US"/>
               <a:t>Click to edit Master title style</a:t>
             </a:r>
-            <a:endParaRPr lang="en-US"/>
           </a:p>
         </p:txBody>
       </p:sp>
@@ -593,38 +604,37 @@
           <a:p>
             <a:pPr lvl="0"/>
             <a:r>
-              <a:rPr lang="en-US" smtClean="0"/>
+              <a:rPr lang="en-US"/>
               <a:t>Click to edit Master text styles</a:t>
             </a:r>
           </a:p>
           <a:p>
             <a:pPr lvl="1"/>
             <a:r>
-              <a:rPr lang="en-US" smtClean="0"/>
+              <a:rPr lang="en-US"/>
               <a:t>Second level</a:t>
             </a:r>
           </a:p>
           <a:p>
             <a:pPr lvl="2"/>
             <a:r>
-              <a:rPr lang="en-US" smtClean="0"/>
+              <a:rPr lang="en-US"/>
               <a:t>Third level</a:t>
             </a:r>
           </a:p>
           <a:p>
             <a:pPr lvl="3"/>
             <a:r>
-              <a:rPr lang="en-US" smtClean="0"/>
+              <a:rPr lang="en-US"/>
               <a:t>Fourth level</a:t>
             </a:r>
           </a:p>
           <a:p>
             <a:pPr lvl="4"/>
             <a:r>
-              <a:rPr lang="en-US" smtClean="0"/>
+              <a:rPr lang="en-US"/>
               <a:t>Fifth level</a:t>
             </a:r>
-            <a:endParaRPr lang="en-US"/>
           </a:p>
         </p:txBody>
       </p:sp>
@@ -645,7 +655,7 @@
           <a:p>
             <a:fld id="{5BCAD085-E8A6-8845-BD4E-CB4CCA059FC4}" type="datetimeFigureOut">
               <a:rPr lang="en-US" smtClean="0"/>
-              <a:t>1/27/13</a:t>
+              <a:t>9/25/2026</a:t>
             </a:fld>
             <a:endParaRPr lang="en-US"/>
           </a:p>
@@ -739,10 +749,9 @@
           <a:lstStyle/>
           <a:p>
             <a:r>
-              <a:rPr lang="en-US" smtClean="0"/>
+              <a:rPr lang="en-US"/>
               <a:t>Click to edit Master title style</a:t>
             </a:r>
-            <a:endParaRPr lang="en-US"/>
           </a:p>
         </p:txBody>
       </p:sp>
@@ -763,38 +772,37 @@
           <a:p>
             <a:pPr lvl="0"/>
             <a:r>
-              <a:rPr lang="en-US" smtClean="0"/>
+              <a:rPr lang="en-US"/>
               <a:t>Click to edit Master text styles</a:t>
             </a:r>
           </a:p>
           <a:p>
             <a:pPr lvl="1"/>
             <a:r>
-              <a:rPr lang="en-US" smtClean="0"/>
+              <a:rPr lang="en-US"/>
               <a:t>Second level</a:t>
             </a:r>
           </a:p>
           <a:p>
             <a:pPr lvl="2"/>
             <a:r>
-              <a:rPr lang="en-US" smtClean="0"/>
+              <a:rPr lang="en-US"/>
               <a:t>Third level</a:t>
             </a:r>
           </a:p>
           <a:p>
             <a:pPr lvl="3"/>
             <a:r>
-              <a:rPr lang="en-US" smtClean="0"/>
+              <a:rPr lang="en-US"/>
               <a:t>Fourth level</a:t>
             </a:r>
           </a:p>
           <a:p>
             <a:pPr lvl="4"/>
             <a:r>
-              <a:rPr lang="en-US" smtClean="0"/>
+              <a:rPr lang="en-US"/>
               <a:t>Fifth level</a:t>
             </a:r>
-            <a:endParaRPr lang="en-US"/>
           </a:p>
         </p:txBody>
       </p:sp>
@@ -815,7 +823,7 @@
           <a:p>
             <a:fld id="{5BCAD085-E8A6-8845-BD4E-CB4CCA059FC4}" type="datetimeFigureOut">
               <a:rPr lang="en-US" smtClean="0"/>
-              <a:t>1/27/13</a:t>
+              <a:t>9/25/2026</a:t>
             </a:fld>
             <a:endParaRPr lang="en-US"/>
           </a:p>
@@ -918,10 +926,9 @@
           </a:lstStyle>
           <a:p>
             <a:r>
-              <a:rPr lang="en-US" smtClean="0"/>
+              <a:rPr lang="en-US"/>
               <a:t>Click to edit Master title style</a:t>
             </a:r>
-            <a:endParaRPr lang="en-US"/>
           </a:p>
         </p:txBody>
       </p:sp>
@@ -1038,7 +1045,7 @@
           <a:p>
             <a:pPr lvl="0"/>
             <a:r>
-              <a:rPr lang="en-US" smtClean="0"/>
+              <a:rPr lang="en-US"/>
               <a:t>Click to edit Master text styles</a:t>
             </a:r>
           </a:p>
@@ -1061,7 +1068,7 @@
           <a:p>
             <a:fld id="{5BCAD085-E8A6-8845-BD4E-CB4CCA059FC4}" type="datetimeFigureOut">
               <a:rPr lang="en-US" smtClean="0"/>
-              <a:t>1/27/13</a:t>
+              <a:t>9/25/2026</a:t>
             </a:fld>
             <a:endParaRPr lang="en-US"/>
           </a:p>
@@ -1155,10 +1162,9 @@
           <a:lstStyle/>
           <a:p>
             <a:r>
-              <a:rPr lang="en-US" smtClean="0"/>
+              <a:rPr lang="en-US"/>
               <a:t>Click to edit Master title style</a:t>
             </a:r>
-            <a:endParaRPr lang="en-US"/>
           </a:p>
         </p:txBody>
       </p:sp>
@@ -1212,38 +1218,37 @@
           <a:p>
             <a:pPr lvl="0"/>
             <a:r>
-              <a:rPr lang="en-US" smtClean="0"/>
+              <a:rPr lang="en-US"/>
               <a:t>Click to edit Master text styles</a:t>
             </a:r>
           </a:p>
           <a:p>
             <a:pPr lvl="1"/>
             <a:r>
-              <a:rPr lang="en-US" smtClean="0"/>
+              <a:rPr lang="en-US"/>
               <a:t>Second level</a:t>
             </a:r>
           </a:p>
           <a:p>
             <a:pPr lvl="2"/>
             <a:r>
-              <a:rPr lang="en-US" smtClean="0"/>
+              <a:rPr lang="en-US"/>
               <a:t>Third level</a:t>
             </a:r>
           </a:p>
           <a:p>
             <a:pPr lvl="3"/>
             <a:r>
-              <a:rPr lang="en-US" smtClean="0"/>
+              <a:rPr lang="en-US"/>
               <a:t>Fourth level</a:t>
             </a:r>
           </a:p>
           <a:p>
             <a:pPr lvl="4"/>
             <a:r>
-              <a:rPr lang="en-US" smtClean="0"/>
+              <a:rPr lang="en-US"/>
               <a:t>Fifth level</a:t>
             </a:r>
-            <a:endParaRPr lang="en-US"/>
           </a:p>
         </p:txBody>
       </p:sp>
@@ -1297,38 +1302,37 @@
           <a:p>
             <a:pPr lvl="0"/>
             <a:r>
-              <a:rPr lang="en-US" smtClean="0"/>
+              <a:rPr lang="en-US"/>
               <a:t>Click to edit Master text styles</a:t>
             </a:r>
           </a:p>
           <a:p>
             <a:pPr lvl="1"/>
             <a:r>
-              <a:rPr lang="en-US" smtClean="0"/>
+              <a:rPr lang="en-US"/>
               <a:t>Second level</a:t>
             </a:r>
           </a:p>
           <a:p>
             <a:pPr lvl="2"/>
             <a:r>
-              <a:rPr lang="en-US" smtClean="0"/>
+              <a:rPr lang="en-US"/>
               <a:t>Third level</a:t>
             </a:r>
           </a:p>
           <a:p>
             <a:pPr lvl="3"/>
             <a:r>
-              <a:rPr lang="en-US" smtClean="0"/>
+              <a:rPr lang="en-US"/>
               <a:t>Fourth level</a:t>
             </a:r>
           </a:p>
           <a:p>
             <a:pPr lvl="4"/>
             <a:r>
-              <a:rPr lang="en-US" smtClean="0"/>
+              <a:rPr lang="en-US"/>
               <a:t>Fifth level</a:t>
             </a:r>
-            <a:endParaRPr lang="en-US"/>
           </a:p>
         </p:txBody>
       </p:sp>
@@ -1349,7 +1353,7 @@
           <a:p>
             <a:fld id="{5BCAD085-E8A6-8845-BD4E-CB4CCA059FC4}" type="datetimeFigureOut">
               <a:rPr lang="en-US" smtClean="0"/>
-              <a:t>1/27/13</a:t>
+              <a:t>9/25/2026</a:t>
             </a:fld>
             <a:endParaRPr lang="en-US"/>
           </a:p>
@@ -1447,10 +1451,9 @@
           </a:lstStyle>
           <a:p>
             <a:r>
-              <a:rPr lang="en-US" smtClean="0"/>
+              <a:rPr lang="en-US"/>
               <a:t>Click to edit Master title style</a:t>
             </a:r>
-            <a:endParaRPr lang="en-US"/>
           </a:p>
         </p:txBody>
       </p:sp>
@@ -1513,7 +1516,7 @@
           <a:p>
             <a:pPr lvl="0"/>
             <a:r>
-              <a:rPr lang="en-US" smtClean="0"/>
+              <a:rPr lang="en-US"/>
               <a:t>Click to edit Master text styles</a:t>
             </a:r>
           </a:p>
@@ -1569,38 +1572,37 @@
           <a:p>
             <a:pPr lvl="0"/>
             <a:r>
-              <a:rPr lang="en-US" smtClean="0"/>
+              <a:rPr lang="en-US"/>
               <a:t>Click to edit Master text styles</a:t>
             </a:r>
           </a:p>
           <a:p>
             <a:pPr lvl="1"/>
             <a:r>
-              <a:rPr lang="en-US" smtClean="0"/>
+              <a:rPr lang="en-US"/>
               <a:t>Second level</a:t>
             </a:r>
           </a:p>
           <a:p>
             <a:pPr lvl="2"/>
             <a:r>
-              <a:rPr lang="en-US" smtClean="0"/>
+              <a:rPr lang="en-US"/>
               <a:t>Third level</a:t>
             </a:r>
           </a:p>
           <a:p>
             <a:pPr lvl="3"/>
             <a:r>
-              <a:rPr lang="en-US" smtClean="0"/>
+              <a:rPr lang="en-US"/>
               <a:t>Fourth level</a:t>
             </a:r>
           </a:p>
           <a:p>
             <a:pPr lvl="4"/>
             <a:r>
-              <a:rPr lang="en-US" smtClean="0"/>
+              <a:rPr lang="en-US"/>
               <a:t>Fifth level</a:t>
             </a:r>
-            <a:endParaRPr lang="en-US"/>
           </a:p>
         </p:txBody>
       </p:sp>
@@ -1663,7 +1665,7 @@
           <a:p>
             <a:pPr lvl="0"/>
             <a:r>
-              <a:rPr lang="en-US" smtClean="0"/>
+              <a:rPr lang="en-US"/>
               <a:t>Click to edit Master text styles</a:t>
             </a:r>
           </a:p>
@@ -1719,38 +1721,37 @@
           <a:p>
             <a:pPr lvl="0"/>
             <a:r>
-              <a:rPr lang="en-US" smtClean="0"/>
+              <a:rPr lang="en-US"/>
               <a:t>Click to edit Master text styles</a:t>
             </a:r>
           </a:p>
           <a:p>
             <a:pPr lvl="1"/>
             <a:r>
-              <a:rPr lang="en-US" smtClean="0"/>
+              <a:rPr lang="en-US"/>
               <a:t>Second level</a:t>
             </a:r>
           </a:p>
           <a:p>
             <a:pPr lvl="2"/>
             <a:r>
-              <a:rPr lang="en-US" smtClean="0"/>
+              <a:rPr lang="en-US"/>
               <a:t>Third level</a:t>
             </a:r>
           </a:p>
           <a:p>
             <a:pPr lvl="3"/>
             <a:r>
-              <a:rPr lang="en-US" smtClean="0"/>
+              <a:rPr lang="en-US"/>
               <a:t>Fourth level</a:t>
             </a:r>
           </a:p>
           <a:p>
             <a:pPr lvl="4"/>
             <a:r>
-              <a:rPr lang="en-US" smtClean="0"/>
+              <a:rPr lang="en-US"/>
               <a:t>Fifth level</a:t>
             </a:r>
-            <a:endParaRPr lang="en-US"/>
           </a:p>
         </p:txBody>
       </p:sp>
@@ -1771,7 +1772,7 @@
           <a:p>
             <a:fld id="{5BCAD085-E8A6-8845-BD4E-CB4CCA059FC4}" type="datetimeFigureOut">
               <a:rPr lang="en-US" smtClean="0"/>
-              <a:t>1/27/13</a:t>
+              <a:t>9/25/2026</a:t>
             </a:fld>
             <a:endParaRPr lang="en-US"/>
           </a:p>
@@ -1865,10 +1866,9 @@
           <a:lstStyle/>
           <a:p>
             <a:r>
-              <a:rPr lang="en-US" smtClean="0"/>
+              <a:rPr lang="en-US"/>
               <a:t>Click to edit Master title style</a:t>
             </a:r>
-            <a:endParaRPr lang="en-US"/>
           </a:p>
         </p:txBody>
       </p:sp>
@@ -1889,7 +1889,7 @@
           <a:p>
             <a:fld id="{5BCAD085-E8A6-8845-BD4E-CB4CCA059FC4}" type="datetimeFigureOut">
               <a:rPr lang="en-US" smtClean="0"/>
-              <a:t>1/27/13</a:t>
+              <a:t>9/25/2026</a:t>
             </a:fld>
             <a:endParaRPr lang="en-US"/>
           </a:p>
@@ -1984,7 +1984,7 @@
           <a:p>
             <a:fld id="{5BCAD085-E8A6-8845-BD4E-CB4CCA059FC4}" type="datetimeFigureOut">
               <a:rPr lang="en-US" smtClean="0"/>
-              <a:t>1/27/13</a:t>
+              <a:t>9/25/2026</a:t>
             </a:fld>
             <a:endParaRPr lang="en-US"/>
           </a:p>
@@ -2087,10 +2087,9 @@
           </a:lstStyle>
           <a:p>
             <a:r>
-              <a:rPr lang="en-US" smtClean="0"/>
+              <a:rPr lang="en-US"/>
               <a:t>Click to edit Master title style</a:t>
             </a:r>
-            <a:endParaRPr lang="en-US"/>
           </a:p>
         </p:txBody>
       </p:sp>
@@ -2144,38 +2143,37 @@
           <a:p>
             <a:pPr lvl="0"/>
             <a:r>
-              <a:rPr lang="en-US" smtClean="0"/>
+              <a:rPr lang="en-US"/>
               <a:t>Click to edit Master text styles</a:t>
             </a:r>
           </a:p>
           <a:p>
             <a:pPr lvl="1"/>
             <a:r>
-              <a:rPr lang="en-US" smtClean="0"/>
+              <a:rPr lang="en-US"/>
               <a:t>Second level</a:t>
             </a:r>
           </a:p>
           <a:p>
             <a:pPr lvl="2"/>
             <a:r>
-              <a:rPr lang="en-US" smtClean="0"/>
+              <a:rPr lang="en-US"/>
               <a:t>Third level</a:t>
             </a:r>
           </a:p>
           <a:p>
             <a:pPr lvl="3"/>
             <a:r>
-              <a:rPr lang="en-US" smtClean="0"/>
+              <a:rPr lang="en-US"/>
               <a:t>Fourth level</a:t>
             </a:r>
           </a:p>
           <a:p>
             <a:pPr lvl="4"/>
             <a:r>
-              <a:rPr lang="en-US" smtClean="0"/>
+              <a:rPr lang="en-US"/>
               <a:t>Fifth level</a:t>
             </a:r>
-            <a:endParaRPr lang="en-US"/>
           </a:p>
         </p:txBody>
       </p:sp>
@@ -2238,7 +2236,7 @@
           <a:p>
             <a:pPr lvl="0"/>
             <a:r>
-              <a:rPr lang="en-US" smtClean="0"/>
+              <a:rPr lang="en-US"/>
               <a:t>Click to edit Master text styles</a:t>
             </a:r>
           </a:p>
@@ -2261,7 +2259,7 @@
           <a:p>
             <a:fld id="{5BCAD085-E8A6-8845-BD4E-CB4CCA059FC4}" type="datetimeFigureOut">
               <a:rPr lang="en-US" smtClean="0"/>
-              <a:t>1/27/13</a:t>
+              <a:t>9/25/2026</a:t>
             </a:fld>
             <a:endParaRPr lang="en-US"/>
           </a:p>
@@ -2364,10 +2362,9 @@
           </a:lstStyle>
           <a:p>
             <a:r>
-              <a:rPr lang="en-US" smtClean="0"/>
+              <a:rPr lang="en-US"/>
               <a:t>Click to edit Master title style</a:t>
             </a:r>
-            <a:endParaRPr lang="en-US"/>
           </a:p>
         </p:txBody>
       </p:sp>
@@ -2491,7 +2488,7 @@
           <a:p>
             <a:pPr lvl="0"/>
             <a:r>
-              <a:rPr lang="en-US" smtClean="0"/>
+              <a:rPr lang="en-US"/>
               <a:t>Click to edit Master text styles</a:t>
             </a:r>
           </a:p>
@@ -2514,7 +2511,7 @@
           <a:p>
             <a:fld id="{5BCAD085-E8A6-8845-BD4E-CB4CCA059FC4}" type="datetimeFigureOut">
               <a:rPr lang="en-US" smtClean="0"/>
-              <a:t>1/27/13</a:t>
+              <a:t>9/25/2026</a:t>
             </a:fld>
             <a:endParaRPr lang="en-US"/>
           </a:p>
@@ -2623,10 +2620,9 @@
           <a:lstStyle/>
           <a:p>
             <a:r>
-              <a:rPr lang="en-US" smtClean="0"/>
+              <a:rPr lang="en-US"/>
               <a:t>Click to edit Master title style</a:t>
             </a:r>
-            <a:endParaRPr lang="en-US"/>
           </a:p>
         </p:txBody>
       </p:sp>
@@ -2657,38 +2653,37 @@
           <a:p>
             <a:pPr lvl="0"/>
             <a:r>
-              <a:rPr lang="en-US" smtClean="0"/>
+              <a:rPr lang="en-US"/>
               <a:t>Click to edit Master text styles</a:t>
             </a:r>
           </a:p>
           <a:p>
             <a:pPr lvl="1"/>
             <a:r>
-              <a:rPr lang="en-US" smtClean="0"/>
+              <a:rPr lang="en-US"/>
               <a:t>Second level</a:t>
             </a:r>
           </a:p>
           <a:p>
             <a:pPr lvl="2"/>
             <a:r>
-              <a:rPr lang="en-US" smtClean="0"/>
+              <a:rPr lang="en-US"/>
               <a:t>Third level</a:t>
             </a:r>
           </a:p>
           <a:p>
             <a:pPr lvl="3"/>
             <a:r>
-              <a:rPr lang="en-US" smtClean="0"/>
+              <a:rPr lang="en-US"/>
               <a:t>Fourth level</a:t>
             </a:r>
           </a:p>
           <a:p>
             <a:pPr lvl="4"/>
             <a:r>
-              <a:rPr lang="en-US" smtClean="0"/>
+              <a:rPr lang="en-US"/>
               <a:t>Fifth level</a:t>
             </a:r>
-            <a:endParaRPr lang="en-US"/>
           </a:p>
         </p:txBody>
       </p:sp>
@@ -2727,7 +2722,7 @@
           <a:p>
             <a:fld id="{5BCAD085-E8A6-8845-BD4E-CB4CCA059FC4}" type="datetimeFigureOut">
               <a:rPr lang="en-US" smtClean="0"/>
-              <a:t>1/27/13</a:t>
+              <a:t>9/25/2026</a:t>
             </a:fld>
             <a:endParaRPr lang="en-US"/>
           </a:p>
@@ -3086,7 +3081,7 @@
 </file>
 
 <file path=ppt/slides/slide1.xml><?xml version="1.0" encoding="utf-8"?>
-<p:sld xmlns:a="http://schemas.openxmlformats.org/drawingml/2006/main" xmlns:p="http://schemas.openxmlformats.org/presentationml/2006/main" xmlns:r="http://schemas.openxmlformats.org/officeDocument/2006/relationships">
+<p:sld xmlns:a="http://schemas.openxmlformats.org/drawingml/2006/main" xmlns:r="http://schemas.openxmlformats.org/officeDocument/2006/relationships" xmlns:p="http://schemas.openxmlformats.org/presentationml/2006/main">
   <p:cSld>
     <p:spTree>
       <p:nvGrpSpPr>
@@ -3094,7 +3089,14 @@
         <p:cNvGrpSpPr/>
         <p:nvPr/>
       </p:nvGrpSpPr>
-      <p:grpSpPr/>
+      <p:grpSpPr>
+        <a:xfrm>
+          <a:off x="0" y="0"/>
+          <a:ext cx="0" cy="0"/>
+          <a:chOff x="0" y="0"/>
+          <a:chExt cx="0" cy="0"/>
+        </a:xfrm>
+      </p:grpSpPr>
       <p:sp>
         <p:nvSpPr>
           <p:cNvPr id="2" name="Rectangle 1"/>
@@ -3135,6 +3137,7 @@
           <a:lstStyle/>
           <a:p>
             <a:pPr algn="ctr"/>
+            <a:endParaRPr/>
           </a:p>
         </p:txBody>
       </p:sp>
@@ -3449,8 +3452,14 @@
               </a:defRPr>
             </a:pPr>
             <a:r>
-              <a:t>Martin Mwai · Solo Technical Founder · Nairobi, Kenya  |  martinmwai.vercel.app</a:t>
-            </a:r>
+              <a:rPr dirty="0"/>
+              <a:t>Martin Mwai · Solo Technical Founder · Nairobi, Kenya  |  </a:t>
+            </a:r>
+            <a:r>
+              <a:rPr dirty="0" err="1"/>
+              <a:t>martinmwai.vercel.app</a:t>
+            </a:r>
+            <a:endParaRPr dirty="0"/>
           </a:p>
         </p:txBody>
       </p:sp>
@@ -3463,7 +3472,7 @@
 </file>
 
 <file path=ppt/slides/slide2.xml><?xml version="1.0" encoding="utf-8"?>
-<p:sld xmlns:a="http://schemas.openxmlformats.org/drawingml/2006/main" xmlns:p="http://schemas.openxmlformats.org/presentationml/2006/main" xmlns:r="http://schemas.openxmlformats.org/officeDocument/2006/relationships">
+<p:sld xmlns:a="http://schemas.openxmlformats.org/drawingml/2006/main" xmlns:r="http://schemas.openxmlformats.org/officeDocument/2006/relationships" xmlns:p="http://schemas.openxmlformats.org/presentationml/2006/main">
   <p:cSld>
     <p:spTree>
       <p:nvGrpSpPr>
@@ -3471,7 +3480,14 @@
         <p:cNvGrpSpPr/>
         <p:nvPr/>
       </p:nvGrpSpPr>
-      <p:grpSpPr/>
+      <p:grpSpPr>
+        <a:xfrm>
+          <a:off x="0" y="0"/>
+          <a:ext cx="0" cy="0"/>
+          <a:chOff x="0" y="0"/>
+          <a:chExt cx="0" cy="0"/>
+        </a:xfrm>
+      </p:grpSpPr>
       <p:sp>
         <p:nvSpPr>
           <p:cNvPr id="2" name="Rectangle 1"/>
@@ -3512,6 +3528,7 @@
           <a:lstStyle/>
           <a:p>
             <a:pPr algn="ctr"/>
+            <a:endParaRPr/>
           </a:p>
         </p:txBody>
       </p:sp>
@@ -3546,6 +3563,7 @@
               </a:defRPr>
             </a:pPr>
             <a:r>
+              <a:rPr dirty="0"/>
               <a:t>THE PROBLEM · GROUNDED REALITY</a:t>
             </a:r>
           </a:p>
@@ -3618,6 +3636,7 @@
               </a:defRPr>
             </a:pPr>
             <a:r>
+              <a:rPr dirty="0"/>
               <a:t>Foundational literacy and applied numeracy gaps compound quietly into permanent economic exclusion.</a:t>
             </a:r>
           </a:p>
@@ -3661,7 +3680,7 @@
           </a:fontRef>
         </p:style>
         <p:txBody>
-          <a:bodyPr rtlCol="0" anchor="ctr" wrap="none"/>
+          <a:bodyPr wrap="none" rtlCol="0" anchor="ctr"/>
           <a:lstStyle/>
           <a:p>
             <a:pPr algn="ctr">
@@ -3756,6 +3775,7 @@
           <a:lstStyle/>
           <a:p>
             <a:pPr algn="ctr"/>
+            <a:endParaRPr/>
           </a:p>
         </p:txBody>
       </p:sp>
@@ -3799,6 +3819,7 @@
           <a:lstStyle/>
           <a:p>
             <a:pPr algn="ctr"/>
+            <a:endParaRPr/>
           </a:p>
         </p:txBody>
       </p:sp>
@@ -3833,6 +3854,7 @@
               </a:defRPr>
             </a:pPr>
             <a:r>
+              <a:rPr dirty="0"/>
               <a:t>A TRUE GROUNDED STORY</a:t>
             </a:r>
           </a:p>
@@ -3849,11 +3871,17 @@
               </a:defRPr>
             </a:pPr>
             <a:r>
+              <a:rPr dirty="0"/>
               <a:t>“On my brother’s first day at a new school, the teacher asked where our parents were. He answered in Kamba instead of Swahili.</a:t>
             </a:r>
-            <a:br/>
-            <a:br/>
-            <a:r>
+            <a:br>
+              <a:rPr dirty="0"/>
+            </a:br>
+            <a:br>
+              <a:rPr dirty="0"/>
+            </a:br>
+            <a:r>
+              <a:rPr dirty="0"/>
               <a:t>In Kenya, language and conceptual gaps don't announce themselves — they become normal.”</a:t>
             </a:r>
           </a:p>
@@ -3870,6 +3898,7 @@
               </a:defRPr>
             </a:pPr>
             <a:r>
+              <a:rPr dirty="0"/>
               <a:t>— Martin Mwai, Founder &amp; Lead Architect</a:t>
             </a:r>
           </a:p>
@@ -3886,6 +3915,7 @@
               </a:defRPr>
             </a:pPr>
             <a:r>
+              <a:rPr dirty="0"/>
               <a:t>Abstract Western EdTech drills ignore this reality. Children fail not from lack of intelligence, but because existing tools assume high-bandwidth connectivity and foreign idioms.</a:t>
             </a:r>
           </a:p>
@@ -3933,6 +3963,7 @@
           <a:lstStyle/>
           <a:p>
             <a:pPr algn="ctr"/>
+            <a:endParaRPr/>
           </a:p>
         </p:txBody>
       </p:sp>
@@ -3976,6 +4007,7 @@
           <a:lstStyle/>
           <a:p>
             <a:pPr algn="ctr"/>
+            <a:endParaRPr/>
           </a:p>
         </p:txBody>
       </p:sp>
@@ -4010,6 +4042,7 @@
               </a:defRPr>
             </a:pPr>
             <a:r>
+              <a:rPr dirty="0"/>
               <a:t>1 in 3</a:t>
             </a:r>
           </a:p>
@@ -4023,6 +4056,7 @@
               </a:defRPr>
             </a:pPr>
             <a:r>
+              <a:rPr dirty="0"/>
               <a:t>Primary learners in East Africa achieve basic arithmetic by Grade 3</a:t>
             </a:r>
           </a:p>
@@ -4036,6 +4070,7 @@
               </a:defRPr>
             </a:pPr>
             <a:r>
+              <a:rPr dirty="0"/>
               <a:t>Over 90% of children in Sub-Saharan Africa cannot read or perform basic arithmetic by age 10.</a:t>
             </a:r>
           </a:p>
@@ -4083,6 +4118,7 @@
           <a:lstStyle/>
           <a:p>
             <a:pPr algn="ctr"/>
+            <a:endParaRPr/>
           </a:p>
         </p:txBody>
       </p:sp>
@@ -4126,6 +4162,7 @@
           <a:lstStyle/>
           <a:p>
             <a:pPr algn="ctr"/>
+            <a:endParaRPr/>
           </a:p>
         </p:txBody>
       </p:sp>
@@ -4160,6 +4197,7 @@
               </a:defRPr>
             </a:pPr>
             <a:r>
+              <a:rPr dirty="0"/>
               <a:t>84%</a:t>
             </a:r>
           </a:p>
@@ -4173,6 +4211,7 @@
               </a:defRPr>
             </a:pPr>
             <a:r>
+              <a:rPr dirty="0"/>
               <a:t>Of Kenya's workforce operates within the informal economy</a:t>
             </a:r>
           </a:p>
@@ -4186,6 +4225,7 @@
               </a:defRPr>
             </a:pPr>
             <a:r>
+              <a:rPr dirty="0"/>
               <a:t>Applied mental math, trade negotiation, and trust are fundamental daily survival skills.</a:t>
             </a:r>
           </a:p>
@@ -4233,6 +4273,7 @@
           <a:lstStyle/>
           <a:p>
             <a:pPr algn="ctr"/>
+            <a:endParaRPr/>
           </a:p>
         </p:txBody>
       </p:sp>
@@ -4276,6 +4317,7 @@
           <a:lstStyle/>
           <a:p>
             <a:pPr algn="ctr"/>
+            <a:endParaRPr/>
           </a:p>
         </p:txBody>
       </p:sp>
@@ -4310,6 +4352,7 @@
               </a:defRPr>
             </a:pPr>
             <a:r>
+              <a:rPr dirty="0"/>
               <a:t>78.3% Offline</a:t>
             </a:r>
           </a:p>
@@ -4323,6 +4366,7 @@
               </a:defRPr>
             </a:pPr>
             <a:r>
+              <a:rPr dirty="0"/>
               <a:t>With only 21.7% rural internet penetration, cloud EdTech fails</a:t>
             </a:r>
           </a:p>
@@ -4336,6 +4380,7 @@
               </a:defRPr>
             </a:pPr>
             <a:r>
+              <a:rPr dirty="0"/>
               <a:t>Mainstream solutions require high-speed continuous data, locking out millions of rural students.</a:t>
             </a:r>
           </a:p>
@@ -4350,7 +4395,7 @@
 </file>
 
 <file path=ppt/slides/slide3.xml><?xml version="1.0" encoding="utf-8"?>
-<p:sld xmlns:a="http://schemas.openxmlformats.org/drawingml/2006/main" xmlns:p="http://schemas.openxmlformats.org/presentationml/2006/main" xmlns:r="http://schemas.openxmlformats.org/officeDocument/2006/relationships">
+<p:sld xmlns:a="http://schemas.openxmlformats.org/drawingml/2006/main" xmlns:r="http://schemas.openxmlformats.org/officeDocument/2006/relationships" xmlns:p="http://schemas.openxmlformats.org/presentationml/2006/main">
   <p:cSld>
     <p:spTree>
       <p:nvGrpSpPr>
@@ -4358,7 +4403,14 @@
         <p:cNvGrpSpPr/>
         <p:nvPr/>
       </p:nvGrpSpPr>
-      <p:grpSpPr/>
+      <p:grpSpPr>
+        <a:xfrm>
+          <a:off x="0" y="0"/>
+          <a:ext cx="0" cy="0"/>
+          <a:chOff x="0" y="0"/>
+          <a:chExt cx="0" cy="0"/>
+        </a:xfrm>
+      </p:grpSpPr>
       <p:sp>
         <p:nvSpPr>
           <p:cNvPr id="2" name="Rectangle 1"/>
@@ -4399,6 +4451,7 @@
           <a:lstStyle/>
           <a:p>
             <a:pPr algn="ctr"/>
+            <a:endParaRPr/>
           </a:p>
         </p:txBody>
       </p:sp>
@@ -4482,7 +4535,7 @@
         </p:nvSpPr>
         <p:spPr>
           <a:xfrm>
-            <a:off x="731520" y="1234440"/>
+            <a:off x="438912" y="1435608"/>
             <a:ext cx="9601200" cy="411480"/>
           </a:xfrm>
           <a:prstGeom prst="rect">
@@ -4505,7 +4558,16 @@
               </a:defRPr>
             </a:pPr>
             <a:r>
-              <a:t>A duka (corner shop) is East Africa's most familiar economic hub. SmartDuka turns it into an adaptive, gamified learning loop.</a:t>
+              <a:rPr dirty="0"/>
+              <a:t>A </a:t>
+            </a:r>
+            <a:r>
+              <a:rPr dirty="0" err="1"/>
+              <a:t>duka</a:t>
+            </a:r>
+            <a:r>
+              <a:rPr dirty="0"/>
+              <a:t> (corner shop) is East Africa's most familiar economic hub. SmartDuka turns it into an adaptive, gamified learning loop.</a:t>
             </a:r>
           </a:p>
         </p:txBody>
@@ -4548,7 +4610,7 @@
           </a:fontRef>
         </p:style>
         <p:txBody>
-          <a:bodyPr rtlCol="0" anchor="ctr" wrap="none"/>
+          <a:bodyPr wrap="none" rtlCol="0" anchor="ctr"/>
           <a:lstStyle/>
           <a:p>
             <a:pPr algn="ctr">
@@ -4643,6 +4705,7 @@
           <a:lstStyle/>
           <a:p>
             <a:pPr algn="ctr"/>
+            <a:endParaRPr/>
           </a:p>
         </p:txBody>
       </p:sp>
@@ -4766,6 +4829,7 @@
               </a:defRPr>
             </a:pPr>
             <a:r>
+              <a:rPr dirty="0"/>
               <a:t>Real-Time NPC Dialogue</a:t>
             </a:r>
           </a:p>
@@ -4805,6 +4869,7 @@
               </a:defRPr>
             </a:pPr>
             <a:r>
+              <a:rPr dirty="0"/>
               <a:t>•  Autonomous customer NPCs speak Sheng, Swahili, and English.</a:t>
             </a:r>
           </a:p>
@@ -4821,6 +4886,7 @@
               </a:defRPr>
             </a:pPr>
             <a:r>
+              <a:rPr dirty="0"/>
               <a:t>•  Dynamic stock negotiation: Customers adapt when goods run low.</a:t>
             </a:r>
           </a:p>
@@ -4837,6 +4903,7 @@
               </a:defRPr>
             </a:pPr>
             <a:r>
+              <a:rPr dirty="0"/>
               <a:t>•  Reinforces CBC Strand 3.0 (Language Comprehension &amp; Vocabulary).</a:t>
             </a:r>
           </a:p>
@@ -4920,6 +4987,7 @@
           <a:lstStyle/>
           <a:p>
             <a:pPr algn="ctr"/>
+            <a:endParaRPr/>
           </a:p>
         </p:txBody>
       </p:sp>
@@ -5007,6 +5075,7 @@
               </a:defRPr>
             </a:pPr>
             <a:r>
+              <a:rPr dirty="0"/>
               <a:t>CALCULATE &amp; TRANSACT</a:t>
             </a:r>
           </a:p>
@@ -5043,6 +5112,7 @@
               </a:defRPr>
             </a:pPr>
             <a:r>
+              <a:rPr dirty="0"/>
               <a:t>Applied Mental Arithmetic</a:t>
             </a:r>
           </a:p>
@@ -5082,6 +5152,7 @@
               </a:defRPr>
             </a:pPr>
             <a:r>
+              <a:rPr dirty="0"/>
               <a:t>•  Kenyan Shilling (KES) currency calculations with coins &amp; notes.</a:t>
             </a:r>
           </a:p>
@@ -5098,6 +5169,7 @@
               </a:defRPr>
             </a:pPr>
             <a:r>
+              <a:rPr dirty="0"/>
               <a:t>•  Fast mental math under natural shop pressure without timed panic.</a:t>
             </a:r>
           </a:p>
@@ -5114,6 +5186,7 @@
               </a:defRPr>
             </a:pPr>
             <a:r>
+              <a:rPr dirty="0"/>
               <a:t>•  Safe-fail pedagogy: Milo mentor gives Socratic hints on repeat error.</a:t>
             </a:r>
           </a:p>
@@ -5197,6 +5270,7 @@
           <a:lstStyle/>
           <a:p>
             <a:pPr algn="ctr"/>
+            <a:endParaRPr/>
           </a:p>
         </p:txBody>
       </p:sp>
@@ -5320,6 +5394,7 @@
               </a:defRPr>
             </a:pPr>
             <a:r>
+              <a:rPr dirty="0"/>
               <a:t>Daftari ya Deni (Credit Ledger)</a:t>
             </a:r>
           </a:p>
@@ -5460,7 +5535,7 @@
 </file>
 
 <file path=ppt/slides/slide4.xml><?xml version="1.0" encoding="utf-8"?>
-<p:sld xmlns:a="http://schemas.openxmlformats.org/drawingml/2006/main" xmlns:p="http://schemas.openxmlformats.org/presentationml/2006/main" xmlns:r="http://schemas.openxmlformats.org/officeDocument/2006/relationships">
+<p:sld xmlns:a="http://schemas.openxmlformats.org/drawingml/2006/main" xmlns:r="http://schemas.openxmlformats.org/officeDocument/2006/relationships" xmlns:p="http://schemas.openxmlformats.org/presentationml/2006/main">
   <p:cSld>
     <p:spTree>
       <p:nvGrpSpPr>
@@ -5468,7 +5543,14 @@
         <p:cNvGrpSpPr/>
         <p:nvPr/>
       </p:nvGrpSpPr>
-      <p:grpSpPr/>
+      <p:grpSpPr>
+        <a:xfrm>
+          <a:off x="0" y="0"/>
+          <a:ext cx="0" cy="0"/>
+          <a:chOff x="0" y="0"/>
+          <a:chExt cx="0" cy="0"/>
+        </a:xfrm>
+      </p:grpSpPr>
       <p:sp>
         <p:nvSpPr>
           <p:cNvPr id="2" name="Rectangle 1"/>
@@ -5509,6 +5591,7 @@
           <a:lstStyle/>
           <a:p>
             <a:pPr algn="ctr"/>
+            <a:endParaRPr/>
           </a:p>
         </p:txBody>
       </p:sp>
@@ -5658,7 +5741,7 @@
           </a:fontRef>
         </p:style>
         <p:txBody>
-          <a:bodyPr rtlCol="0" anchor="ctr" wrap="none"/>
+          <a:bodyPr wrap="none" rtlCol="0" anchor="ctr"/>
           <a:lstStyle/>
           <a:p>
             <a:pPr algn="ctr">
@@ -5801,6 +5884,7 @@
           <a:lstStyle/>
           <a:p>
             <a:pPr algn="ctr"/>
+            <a:endParaRPr/>
           </a:p>
         </p:txBody>
       </p:sp>
@@ -5844,6 +5928,7 @@
           <a:lstStyle/>
           <a:p>
             <a:pPr algn="ctr"/>
+            <a:endParaRPr/>
           </a:p>
         </p:txBody>
       </p:sp>
@@ -5977,6 +6062,7 @@
           <a:lstStyle/>
           <a:p>
             <a:pPr algn="ctr"/>
+            <a:endParaRPr/>
           </a:p>
         </p:txBody>
       </p:sp>
@@ -6020,6 +6106,7 @@
           <a:lstStyle/>
           <a:p>
             <a:pPr algn="ctr"/>
+            <a:endParaRPr/>
           </a:p>
         </p:txBody>
       </p:sp>
@@ -6153,6 +6240,7 @@
           <a:lstStyle/>
           <a:p>
             <a:pPr algn="ctr"/>
+            <a:endParaRPr/>
           </a:p>
         </p:txBody>
       </p:sp>
@@ -6196,6 +6284,7 @@
           <a:lstStyle/>
           <a:p>
             <a:pPr algn="ctr"/>
+            <a:endParaRPr/>
           </a:p>
         </p:txBody>
       </p:sp>
@@ -6338,7 +6427,7 @@
 </file>
 
 <file path=ppt/slides/slide5.xml><?xml version="1.0" encoding="utf-8"?>
-<p:sld xmlns:a="http://schemas.openxmlformats.org/drawingml/2006/main" xmlns:p="http://schemas.openxmlformats.org/presentationml/2006/main" xmlns:r="http://schemas.openxmlformats.org/officeDocument/2006/relationships">
+<p:sld xmlns:a="http://schemas.openxmlformats.org/drawingml/2006/main" xmlns:r="http://schemas.openxmlformats.org/officeDocument/2006/relationships" xmlns:p="http://schemas.openxmlformats.org/presentationml/2006/main">
   <p:cSld>
     <p:spTree>
       <p:nvGrpSpPr>
@@ -6346,7 +6435,14 @@
         <p:cNvGrpSpPr/>
         <p:nvPr/>
       </p:nvGrpSpPr>
-      <p:grpSpPr/>
+      <p:grpSpPr>
+        <a:xfrm>
+          <a:off x="0" y="0"/>
+          <a:ext cx="0" cy="0"/>
+          <a:chOff x="0" y="0"/>
+          <a:chExt cx="0" cy="0"/>
+        </a:xfrm>
+      </p:grpSpPr>
       <p:sp>
         <p:nvSpPr>
           <p:cNvPr id="2" name="Rectangle 1"/>
@@ -6387,6 +6483,7 @@
           <a:lstStyle/>
           <a:p>
             <a:pPr algn="ctr"/>
+            <a:endParaRPr/>
           </a:p>
         </p:txBody>
       </p:sp>
@@ -6536,7 +6633,7 @@
           </a:fontRef>
         </p:style>
         <p:txBody>
-          <a:bodyPr rtlCol="0" anchor="ctr" wrap="none"/>
+          <a:bodyPr wrap="none" rtlCol="0" anchor="ctr"/>
           <a:lstStyle/>
           <a:p>
             <a:pPr algn="ctr">
@@ -6631,6 +6728,7 @@
           <a:lstStyle/>
           <a:p>
             <a:pPr algn="ctr"/>
+            <a:endParaRPr/>
           </a:p>
         </p:txBody>
       </p:sp>
@@ -6865,6 +6963,7 @@
           <a:lstStyle/>
           <a:p>
             <a:pPr algn="ctr"/>
+            <a:endParaRPr/>
           </a:p>
         </p:txBody>
       </p:sp>
@@ -7099,6 +7198,7 @@
           <a:lstStyle/>
           <a:p>
             <a:pPr algn="ctr"/>
+            <a:endParaRPr/>
           </a:p>
         </p:txBody>
       </p:sp>
@@ -7355,7 +7455,7 @@
 </file>
 
 <file path=ppt/slides/slide6.xml><?xml version="1.0" encoding="utf-8"?>
-<p:sld xmlns:a="http://schemas.openxmlformats.org/drawingml/2006/main" xmlns:p="http://schemas.openxmlformats.org/presentationml/2006/main" xmlns:r="http://schemas.openxmlformats.org/officeDocument/2006/relationships">
+<p:sld xmlns:a="http://schemas.openxmlformats.org/drawingml/2006/main" xmlns:r="http://schemas.openxmlformats.org/officeDocument/2006/relationships" xmlns:p="http://schemas.openxmlformats.org/presentationml/2006/main">
   <p:cSld>
     <p:spTree>
       <p:nvGrpSpPr>
@@ -7363,7 +7463,14 @@
         <p:cNvGrpSpPr/>
         <p:nvPr/>
       </p:nvGrpSpPr>
-      <p:grpSpPr/>
+      <p:grpSpPr>
+        <a:xfrm>
+          <a:off x="0" y="0"/>
+          <a:ext cx="0" cy="0"/>
+          <a:chOff x="0" y="0"/>
+          <a:chExt cx="0" cy="0"/>
+        </a:xfrm>
+      </p:grpSpPr>
       <p:sp>
         <p:nvSpPr>
           <p:cNvPr id="2" name="Rectangle 1"/>
@@ -7404,6 +7511,7 @@
           <a:lstStyle/>
           <a:p>
             <a:pPr algn="ctr"/>
+            <a:endParaRPr/>
           </a:p>
         </p:txBody>
       </p:sp>
@@ -7553,7 +7661,7 @@
           </a:fontRef>
         </p:style>
         <p:txBody>
-          <a:bodyPr rtlCol="0" anchor="ctr" wrap="none"/>
+          <a:bodyPr wrap="none" rtlCol="0" anchor="ctr"/>
           <a:lstStyle/>
           <a:p>
             <a:pPr algn="ctr">
@@ -7648,6 +7756,7 @@
           <a:lstStyle/>
           <a:p>
             <a:pPr algn="ctr"/>
+            <a:endParaRPr/>
           </a:p>
         </p:txBody>
       </p:sp>
@@ -7882,6 +7991,7 @@
           <a:lstStyle/>
           <a:p>
             <a:pPr algn="ctr"/>
+            <a:endParaRPr/>
           </a:p>
         </p:txBody>
       </p:sp>
@@ -8116,6 +8226,7 @@
           <a:lstStyle/>
           <a:p>
             <a:pPr algn="ctr"/>
+            <a:endParaRPr/>
           </a:p>
         </p:txBody>
       </p:sp>
@@ -8350,6 +8461,7 @@
           <a:lstStyle/>
           <a:p>
             <a:pPr algn="ctr"/>
+            <a:endParaRPr/>
           </a:p>
         </p:txBody>
       </p:sp>
@@ -8606,7 +8718,7 @@
 </file>
 
 <file path=ppt/slides/slide7.xml><?xml version="1.0" encoding="utf-8"?>
-<p:sld xmlns:a="http://schemas.openxmlformats.org/drawingml/2006/main" xmlns:p="http://schemas.openxmlformats.org/presentationml/2006/main" xmlns:r="http://schemas.openxmlformats.org/officeDocument/2006/relationships">
+<p:sld xmlns:a="http://schemas.openxmlformats.org/drawingml/2006/main" xmlns:r="http://schemas.openxmlformats.org/officeDocument/2006/relationships" xmlns:p="http://schemas.openxmlformats.org/presentationml/2006/main">
   <p:cSld>
     <p:spTree>
       <p:nvGrpSpPr>
@@ -8614,7 +8726,14 @@
         <p:cNvGrpSpPr/>
         <p:nvPr/>
       </p:nvGrpSpPr>
-      <p:grpSpPr/>
+      <p:grpSpPr>
+        <a:xfrm>
+          <a:off x="0" y="0"/>
+          <a:ext cx="0" cy="0"/>
+          <a:chOff x="0" y="0"/>
+          <a:chExt cx="0" cy="0"/>
+        </a:xfrm>
+      </p:grpSpPr>
       <p:sp>
         <p:nvSpPr>
           <p:cNvPr id="2" name="Rectangle 1"/>
@@ -8655,6 +8774,7 @@
           <a:lstStyle/>
           <a:p>
             <a:pPr algn="ctr"/>
+            <a:endParaRPr/>
           </a:p>
         </p:txBody>
       </p:sp>
@@ -8804,7 +8924,7 @@
           </a:fontRef>
         </p:style>
         <p:txBody>
-          <a:bodyPr rtlCol="0" anchor="ctr" wrap="none"/>
+          <a:bodyPr wrap="none" rtlCol="0" anchor="ctr"/>
           <a:lstStyle/>
           <a:p>
             <a:pPr algn="ctr">
@@ -8899,6 +9019,7 @@
           <a:lstStyle/>
           <a:p>
             <a:pPr algn="ctr"/>
+            <a:endParaRPr/>
           </a:p>
         </p:txBody>
       </p:sp>
@@ -9167,6 +9288,7 @@
           <a:lstStyle/>
           <a:p>
             <a:pPr algn="ctr"/>
+            <a:endParaRPr/>
           </a:p>
         </p:txBody>
       </p:sp>
@@ -9382,7 +9504,7 @@
 </file>
 
 <file path=ppt/slides/slide8.xml><?xml version="1.0" encoding="utf-8"?>
-<p:sld xmlns:a="http://schemas.openxmlformats.org/drawingml/2006/main" xmlns:p="http://schemas.openxmlformats.org/presentationml/2006/main" xmlns:r="http://schemas.openxmlformats.org/officeDocument/2006/relationships">
+<p:sld xmlns:a="http://schemas.openxmlformats.org/drawingml/2006/main" xmlns:r="http://schemas.openxmlformats.org/officeDocument/2006/relationships" xmlns:p="http://schemas.openxmlformats.org/presentationml/2006/main">
   <p:cSld>
     <p:spTree>
       <p:nvGrpSpPr>
@@ -9390,7 +9512,14 @@
         <p:cNvGrpSpPr/>
         <p:nvPr/>
       </p:nvGrpSpPr>
-      <p:grpSpPr/>
+      <p:grpSpPr>
+        <a:xfrm>
+          <a:off x="0" y="0"/>
+          <a:ext cx="0" cy="0"/>
+          <a:chOff x="0" y="0"/>
+          <a:chExt cx="0" cy="0"/>
+        </a:xfrm>
+      </p:grpSpPr>
       <p:sp>
         <p:nvSpPr>
           <p:cNvPr id="2" name="Rectangle 1"/>
@@ -9431,6 +9560,7 @@
           <a:lstStyle/>
           <a:p>
             <a:pPr algn="ctr"/>
+            <a:endParaRPr/>
           </a:p>
         </p:txBody>
       </p:sp>
@@ -9580,7 +9710,7 @@
           </a:fontRef>
         </p:style>
         <p:txBody>
-          <a:bodyPr rtlCol="0" anchor="ctr" wrap="none"/>
+          <a:bodyPr wrap="none" rtlCol="0" anchor="ctr"/>
           <a:lstStyle/>
           <a:p>
             <a:pPr algn="ctr">
@@ -9675,6 +9805,7 @@
           <a:lstStyle/>
           <a:p>
             <a:pPr algn="ctr"/>
+            <a:endParaRPr/>
           </a:p>
         </p:txBody>
       </p:sp>
@@ -9841,6 +9972,7 @@
           <a:lstStyle/>
           <a:p>
             <a:pPr algn="ctr"/>
+            <a:endParaRPr/>
           </a:p>
         </p:txBody>
       </p:sp>
@@ -10007,6 +10139,7 @@
           <a:lstStyle/>
           <a:p>
             <a:pPr algn="ctr"/>
+            <a:endParaRPr/>
           </a:p>
         </p:txBody>
       </p:sp>
@@ -10169,7 +10302,7 @@
           </a:fontRef>
         </p:style>
         <p:txBody>
-          <a:bodyPr rtlCol="0" anchor="ctr" wrap="square"/>
+          <a:bodyPr wrap="square" rtlCol="0" anchor="ctr"/>
           <a:lstStyle/>
           <a:p>
             <a:pPr algn="ctr">
@@ -10264,7 +10397,7 @@
           </a:fontRef>
         </p:style>
         <p:txBody>
-          <a:bodyPr rtlCol="0" anchor="ctr" wrap="square"/>
+          <a:bodyPr wrap="square" rtlCol="0" anchor="ctr"/>
           <a:lstStyle/>
           <a:p>
             <a:pPr algn="ctr">

</xml_diff>